<commit_message>
Use 35-year project duration in VCU slide
Co-Authored-By: Claude Opus 5.5 <noreply@anthropic.com>
Claude-Session: https://claude.ai/code/session_0128JWd9b3aG69FmvzFL569j
</commit_message>
<xml_diff>
--- a/FINAL_VCU_Nilai_Karbon_Plan_Vivo.pptx
+++ b/FINAL_VCU_Nilai_Karbon_Plan_Vivo.pptx
@@ -107,7 +107,7 @@
   <p:extLst>
     <p:ext uri="{521415D9-36F7-43E2-AB2F-B90AF26B5E84}">
       <p14:sectionLst xmlns:p14="http://schemas.microsoft.com/office/powerpoint/2010/main">
-        <p14:section name="VCU dan nilai karbon" id="{7b303eba-637a-d748-a986-0deccc9cb4be}">
+        <p14:section name="VCU dan nilai karbon" id="{fab985c1-acb9-a8b7-4724-db555a871b48}">
           <p14:sldIdLst>
             <p14:sldId id="256"/>
           </p14:sldIdLst>
@@ -516,7 +516,7 @@
           <a:p>
             <a:r>
               <a:rPr lang="en-US" dirty="0"/>
-              <a:t>Estimasi awal dengan rumus terkoreksi. REDD+ biomassa = 8,29 ha/tahun × 100 tC/ha × 44/12 = 3.040 tCO2e/tahun. REDD+ gambut = 8,29 × 16 tCO2e/ha/tahun × rata-rata 10.5 tahun berjalan = 1.393. ARR = 591,26 ha × 8 tCO2e/ha/tahun = 4.730. Total 9.162, dipotong buffer 35% (3.207) = 5.956 unit/tahun, 119.112 unit selama 20 tahun. Karbon biomassa 100 tC/ha dan serapan ARR 8 tCO2e/ha/tahun adalah asumsi; ganti dengan FREL KLHK/plot lapangan. Pendapatan kotor: belum dikurangi biaya validasi, registrasi, MRV, restorasi; belum memperhitungkan masa tumbuh ARR dan kebocoran. Plan Vivo menerbitkan Plan Vivo Certificate (PVC); 1 unit = 1 tCO2e. Angka spreadsheet (6,34 dan 13.745 unit/tahun) tidak dipakai karena rumusnya salah.</a:t>
+              <a:t>Estimasi awal dengan rumus terkoreksi. REDD+ biomassa = 8,29 ha/tahun × 100 tC/ha × 44/12 = 3.040 tCO2e/tahun. REDD+ gambut = 8,29 × 16 tCO2e/ha/tahun × rata-rata 18 tahun berjalan = 2.388. ARR = 591,26 ha × 8 tCO2e/ha/tahun = 4.730. Total 10.157, dipotong buffer 35% (3.555) = 6.602 unit/tahun, 231.078 unit selama 35 tahun. Karbon biomassa 100 tC/ha dan serapan ARR 8 tCO2e/ha/tahun adalah asumsi; ganti dengan FREL KLHK/plot lapangan. Pendapatan kotor: belum dikurangi biaya validasi, registrasi, MRV, restorasi; belum memperhitungkan masa tumbuh ARR dan kebocoran. Plan Vivo menerbitkan Plan Vivo Certificate (PVC); 1 unit = 1 tCO2e. Angka spreadsheet (6,34 dan 13.745 unit/tahun) tidak dipakai karena rumusnya salah.</a:t>
             </a:r>
             <a:endParaRPr lang="en-US" dirty="0"/>
           </a:p>
@@ -1069,7 +1069,7 @@
                 <a:ea typeface="Cambria" pitchFamily="34" charset="-122"/>
                 <a:cs typeface="Cambria" pitchFamily="34" charset="-120"/>
               </a:rPr>
-              <a:t>±5.956 unit per tahun, senilai Rp 953 juta pada US$10</a:t>
+              <a:t>±6.602 unit per tahun, senilai Rp 1,06 miliar pada US$10</a:t>
             </a:r>
             <a:endParaRPr lang="en-US" sz="2800" dirty="0"/>
           </a:p>
@@ -1170,7 +1170,7 @@
         <p:spPr>
           <a:xfrm>
             <a:off x="2834640" y="2103120"/>
-            <a:ext cx="925230" cy="274320"/>
+            <a:ext cx="834613" cy="274320"/>
           </a:xfrm>
           <a:prstGeom prst="rect">
             <a:avLst/>
@@ -1284,7 +1284,7 @@
                   <a:srgbClr val="5F6B65"/>
                 </a:solidFill>
               </a:rPr>
-              <a:t>Terhindar, rata-rata 20 th</a:t>
+              <a:t>Terhindar, rata-rata 35 th</a:t>
             </a:r>
             <a:endParaRPr lang="en-US" sz="1400" dirty="0"/>
           </a:p>
@@ -1298,8 +1298,8 @@
         </p:nvSpPr>
         <p:spPr>
           <a:xfrm>
-            <a:off x="3759870" y="2706624"/>
-            <a:ext cx="423923" cy="274320"/>
+            <a:off x="3669253" y="2706624"/>
+            <a:ext cx="655551" cy="274320"/>
           </a:xfrm>
           <a:prstGeom prst="rect">
             <a:avLst/>
@@ -1340,7 +1340,7 @@
                   <a:schemeClr val="tx1"/>
                 </a:solidFill>
               </a:rPr>
-              <a:t>1.393</a:t>
+              <a:t>2.388</a:t>
             </a:r>
             <a:endParaRPr lang="en-US" sz="1400" dirty="0"/>
           </a:p>
@@ -1427,8 +1427,8 @@
         </p:nvSpPr>
         <p:spPr>
           <a:xfrm>
-            <a:off x="4183793" y="3310128"/>
-            <a:ext cx="1439767" cy="274320"/>
+            <a:off x="4324804" y="3310128"/>
+            <a:ext cx="1298756" cy="274320"/>
           </a:xfrm>
           <a:prstGeom prst="rect">
             <a:avLst/>
@@ -1598,7 +1598,7 @@
                   <a:schemeClr val="accent3"/>
                 </a:solidFill>
               </a:rPr>
-              <a:t>− 3.207</a:t>
+              <a:t>− 3.555</a:t>
             </a:r>
             <a:endParaRPr lang="en-US" sz="1400" dirty="0"/>
           </a:p>
@@ -1671,7 +1671,7 @@
                   <a:srgbClr val="5F6B65"/>
                 </a:solidFill>
               </a:rPr>
-              <a:t>119.112 unit selama 20 tahun</a:t>
+              <a:t>231.078 unit selama 35 tahun</a:t>
             </a:r>
             <a:endParaRPr lang="en-US" sz="1500" dirty="0"/>
           </a:p>
@@ -1730,7 +1730,7 @@
                 <a:ea typeface="Cambria" pitchFamily="34" charset="-122"/>
                 <a:cs typeface="Cambria" pitchFamily="34" charset="-120"/>
               </a:rPr>
-              <a:t>5.956</a:t>
+              <a:t>6.602</a:t>
             </a:r>
             <a:endParaRPr lang="en-US" sz="2000" dirty="0"/>
           </a:p>
@@ -1959,7 +1959,7 @@
                           <a:ea typeface="Calibri" pitchFamily="34" charset="-122"/>
                           <a:cs typeface="Calibri" pitchFamily="34" charset="-120"/>
                         </a:rPr>
-                        <a:t>Total 20 th</a:t>
+                        <a:t>Total 35 th</a:t>
                       </a:r>
                       <a:endParaRPr lang="en-US" sz="1100" dirty="0">
                         <a:latin typeface="Calibri" charset="0"/>
@@ -2055,7 +2055,7 @@
                           <a:ea typeface="Calibri" pitchFamily="34" charset="-122"/>
                           <a:cs typeface="Calibri" pitchFamily="34" charset="-120"/>
                         </a:rPr>
-                        <a:t>Rp 286 jt</a:t>
+                        <a:t>Rp 317 jt</a:t>
                       </a:r>
                       <a:endParaRPr lang="en-US" sz="1400" dirty="0">
                         <a:latin typeface="Calibri" charset="0"/>
@@ -2102,7 +2102,7 @@
                           <a:ea typeface="Calibri" pitchFamily="34" charset="-122"/>
                           <a:cs typeface="Calibri" pitchFamily="34" charset="-120"/>
                         </a:rPr>
-                        <a:t>Rp 172 jt</a:t>
+                        <a:t>Rp 190 jt</a:t>
                       </a:r>
                       <a:endParaRPr lang="en-US" sz="1400" dirty="0">
                         <a:latin typeface="Calibri" charset="0"/>
@@ -2149,7 +2149,7 @@
                           <a:ea typeface="Calibri" pitchFamily="34" charset="-122"/>
                           <a:cs typeface="Calibri" pitchFamily="34" charset="-120"/>
                         </a:rPr>
-                        <a:t>Rp 5,72 M</a:t>
+                        <a:t>Rp 11,09 M</a:t>
                       </a:r>
                       <a:endParaRPr lang="en-US" sz="1400" dirty="0">
                         <a:latin typeface="Calibri" charset="0"/>
@@ -2245,7 +2245,7 @@
                           <a:ea typeface="Calibri" pitchFamily="34" charset="-122"/>
                           <a:cs typeface="Calibri" pitchFamily="34" charset="-120"/>
                         </a:rPr>
-                        <a:t>Rp 476 jt</a:t>
+                        <a:t>Rp 528 jt</a:t>
                       </a:r>
                       <a:endParaRPr lang="en-US" sz="1400" dirty="0">
                         <a:latin typeface="Calibri" charset="0"/>
@@ -2292,7 +2292,7 @@
                           <a:ea typeface="Calibri" pitchFamily="34" charset="-122"/>
                           <a:cs typeface="Calibri" pitchFamily="34" charset="-120"/>
                         </a:rPr>
-                        <a:t>Rp 286 jt</a:t>
+                        <a:t>Rp 317 jt</a:t>
                       </a:r>
                       <a:endParaRPr lang="en-US" sz="1400" dirty="0">
                         <a:latin typeface="Calibri" charset="0"/>
@@ -2339,7 +2339,7 @@
                           <a:ea typeface="Calibri" pitchFamily="34" charset="-122"/>
                           <a:cs typeface="Calibri" pitchFamily="34" charset="-120"/>
                         </a:rPr>
-                        <a:t>Rp 9,53 M</a:t>
+                        <a:t>Rp 18,49 M</a:t>
                       </a:r>
                       <a:endParaRPr lang="en-US" sz="1400" dirty="0">
                         <a:latin typeface="Calibri" charset="0"/>
@@ -2438,7 +2438,7 @@
                           <a:ea typeface="Calibri" pitchFamily="34" charset="-122"/>
                           <a:cs typeface="Calibri" pitchFamily="34" charset="-120"/>
                         </a:rPr>
-                        <a:t>Rp 953 jt</a:t>
+                        <a:t>Rp 1,06 M</a:t>
                       </a:r>
                       <a:endParaRPr lang="en-US" sz="1400" dirty="0">
                         <a:latin typeface="Calibri" charset="0"/>
@@ -2488,7 +2488,7 @@
                           <a:ea typeface="Calibri" pitchFamily="34" charset="-122"/>
                           <a:cs typeface="Calibri" pitchFamily="34" charset="-120"/>
                         </a:rPr>
-                        <a:t>Rp 572 jt</a:t>
+                        <a:t>Rp 634 jt</a:t>
                       </a:r>
                       <a:endParaRPr lang="en-US" sz="1400" dirty="0">
                         <a:latin typeface="Calibri" charset="0"/>
@@ -2538,7 +2538,7 @@
                           <a:ea typeface="Calibri" pitchFamily="34" charset="-122"/>
                           <a:cs typeface="Calibri" pitchFamily="34" charset="-120"/>
                         </a:rPr>
-                        <a:t>Rp 19,06 M</a:t>
+                        <a:t>Rp 36,97 M</a:t>
                       </a:r>
                       <a:endParaRPr lang="en-US" sz="1400" dirty="0">
                         <a:latin typeface="Calibri" charset="0"/>
@@ -2637,7 +2637,7 @@
                           <a:ea typeface="Calibri" pitchFamily="34" charset="-122"/>
                           <a:cs typeface="Calibri" pitchFamily="34" charset="-120"/>
                         </a:rPr>
-                        <a:t>Rp 1,43 M</a:t>
+                        <a:t>Rp 1,58 M</a:t>
                       </a:r>
                       <a:endParaRPr lang="en-US" sz="1400" dirty="0">
                         <a:latin typeface="Calibri" charset="0"/>
@@ -2684,7 +2684,7 @@
                           <a:ea typeface="Calibri" pitchFamily="34" charset="-122"/>
                           <a:cs typeface="Calibri" pitchFamily="34" charset="-120"/>
                         </a:rPr>
-                        <a:t>Rp 858 jt</a:t>
+                        <a:t>Rp 951 jt</a:t>
                       </a:r>
                       <a:endParaRPr lang="en-US" sz="1400" dirty="0">
                         <a:latin typeface="Calibri" charset="0"/>
@@ -2731,7 +2731,7 @@
                           <a:ea typeface="Calibri" pitchFamily="34" charset="-122"/>
                           <a:cs typeface="Calibri" pitchFamily="34" charset="-120"/>
                         </a:rPr>
-                        <a:t>Rp 28,59 M</a:t>
+                        <a:t>Rp 55,46 M</a:t>
                       </a:r>
                       <a:endParaRPr lang="en-US" sz="1400" dirty="0">
                         <a:latin typeface="Calibri" charset="0"/>
@@ -2799,7 +2799,7 @@
                 <a:ea typeface="Cambria" pitchFamily="34" charset="-122"/>
                 <a:cs typeface="Cambria" pitchFamily="34" charset="-120"/>
               </a:rPr>
-              <a:t>Rp 572 juta</a:t>
+              <a:t>Rp 634 juta</a:t>
             </a:r>
             <a:pPr indent="0" marL="0">
               <a:buNone/>
@@ -2846,7 +2846,7 @@
                   <a:srgbClr val="5F6B65"/>
                 </a:solidFill>
               </a:rPr>
-              <a:t>Rp 11,4 miliar selama 20 tahun · pendapatan kotor, sebelum biaya proyek</a:t>
+              <a:t>Rp 22,2 miliar selama 35 tahun · pendapatan kotor, sebelum biaya proyek</a:t>
             </a:r>
             <a:endParaRPr lang="en-US" sz="1200" dirty="0"/>
           </a:p>

</xml_diff>